<commit_message>
up to random effects 13
</commit_message>
<xml_diff>
--- a/docs/ecostats_lectures/lecture_12/12_01_lecture_powerpoint.pptx
+++ b/docs/ecostats_lectures/lecture_12/12_01_lecture_powerpoint.pptx
@@ -4201,9 +4201,40 @@
               <a:rPr>
                 <a:latin typeface="Courier"/>
               </a:rPr>
-              <a:t>[1] "Combined table with means and counts:"</a:t>
-            </a:r>
-          </a:p>
+              <a:t>## Combined table with means and counts:
+## # A tibble: 3 × 5
+##   species   female_mean male_mean female_n male_n
+##   &lt;fct&gt;           &lt;dbl&gt;     &lt;dbl&gt;    &lt;int&gt;  &lt;int&gt;
+## 1 Adelie          3369.     4043.       73     73
+## 2 Chinstrap       3527.     3939.       34     34
+## 3 Gentoo          4680.     5485.       58     61
+## 
+## 
+## Regular means (WRONG for marginal means):
+## # A tibble: 3 × 3
+##   species   total_n regular_mean
+##   &lt;fct&gt;       &lt;int&gt;        &lt;dbl&gt;
+## 1 Adelie        146        3706.
+## 2 Chinstrap      68        3733.
+## 3 Gentoo        119        5092.</a:t>
+            </a:r>
+          </a:p>
+        </p:txBody>
+      </p:sp>
+      <p:sp>
+        <p:nvSpPr>
+          <p:cNvPr id="4" name="Content Placeholder 3"/>
+          <p:cNvSpPr>
+            <a:spLocks noGrp="1"/>
+          </p:cNvSpPr>
+          <p:nvPr>
+            <p:ph idx="2" sz="half"/>
+          </p:nvPr>
+        </p:nvSpPr>
+        <p:spPr/>
+        <p:txBody>
+          <a:bodyPr/>
+          <a:lstStyle/>
           <a:p>
             <a:pPr lvl="0" indent="0">
               <a:buNone/>
@@ -4212,109 +4243,22 @@
               <a:rPr>
                 <a:latin typeface="Courier"/>
               </a:rPr>
-              <a:t># A tibble: 3 × 5
-  species   female_mean male_mean female_n male_n
-  &lt;fct&gt;           &lt;dbl&gt;     &lt;dbl&gt;    &lt;int&gt;  &lt;int&gt;
-1 Adelie          3369.     4043.       73     73
-2 Chinstrap       3527.     3939.       34     34
-3 Gentoo          4680.     5485.       58     61</a:t>
-            </a:r>
-          </a:p>
-          <a:p>
-            <a:pPr lvl="0" indent="0">
-              <a:buNone/>
-            </a:pPr>
-            <a:r>
-              <a:rPr>
-                <a:latin typeface="Courier"/>
-              </a:rPr>
-              <a:t>[1] "\nRegular means (WRONG for marginal means):"</a:t>
-            </a:r>
-          </a:p>
-          <a:p>
-            <a:pPr lvl="0" indent="0">
-              <a:buNone/>
-            </a:pPr>
-            <a:r>
-              <a:rPr>
-                <a:latin typeface="Courier"/>
-              </a:rPr>
-              <a:t># A tibble: 3 × 3
-  species   total_n regular_mean
-  &lt;fct&gt;       &lt;int&gt;        &lt;dbl&gt;
-1 Adelie        146        3706.
-2 Chinstrap      68        3733.
-3 Gentoo        119        5092.</a:t>
-            </a:r>
-          </a:p>
-        </p:txBody>
-      </p:sp>
-      <p:sp>
-        <p:nvSpPr>
-          <p:cNvPr id="4" name="Content Placeholder 3"/>
-          <p:cNvSpPr>
-            <a:spLocks noGrp="1"/>
-          </p:cNvSpPr>
-          <p:nvPr>
-            <p:ph idx="2" sz="half"/>
-          </p:nvPr>
-        </p:nvSpPr>
-        <p:spPr/>
-        <p:txBody>
-          <a:bodyPr/>
-          <a:lstStyle/>
-          <a:p>
-            <a:pPr lvl="0" indent="0">
-              <a:buNone/>
-            </a:pPr>
-            <a:r>
-              <a:rPr>
-                <a:latin typeface="Courier"/>
-              </a:rPr>
-              <a:t>[1] "Estimated Marginal Means for Species (CORRECT):"</a:t>
-            </a:r>
-          </a:p>
-          <a:p>
-            <a:pPr lvl="0" indent="0">
-              <a:buNone/>
-            </a:pPr>
-            <a:r>
-              <a:rPr>
-                <a:latin typeface="Courier"/>
-              </a:rPr>
-              <a:t># A tibble: 3 × 3
-  species   emm_mean calculation                   
-  &lt;fct&gt;        &lt;dbl&gt; &lt;chr&gt;                         
-1 Adelie       3706. (3368.8 + 4043.5) / 2 = 3706.2
-2 Chinstrap    3733. (3527.2 + 3939) / 2 = 3733.1  
-3 Gentoo       5082. (4679.7 + 5484.8) / 2 = 5082.3</a:t>
-            </a:r>
-          </a:p>
-          <a:p>
-            <a:pPr lvl="0" indent="0">
-              <a:buNone/>
-            </a:pPr>
-            <a:r>
-              <a:rPr>
-                <a:latin typeface="Courier"/>
-              </a:rPr>
-              <a:t>[1] "\nComparison showing EMM calculation:"</a:t>
-            </a:r>
-          </a:p>
-          <a:p>
-            <a:pPr lvl="0" indent="0">
-              <a:buNone/>
-            </a:pPr>
-            <a:r>
-              <a:rPr>
-                <a:latin typeface="Courier"/>
-              </a:rPr>
-              <a:t># A tibble: 3 × 6
-  species   cell_mean_female cell_mean_male species_emm regular_mean difference
-  &lt;fct&gt;                &lt;dbl&gt;          &lt;dbl&gt;       &lt;dbl&gt;        &lt;dbl&gt;      &lt;dbl&gt;
-1 Adelie               3369.          4043.       3706.        3706.   4.55e-13
-2 Chinstrap            3527.          3939.       3733.        3733.   0       
-3 Gentoo               4680.          5485.       5082.        5092.  -1.01e+ 1</a:t>
+              <a:t>## Estimated Marginal Means for Species (CORRECT):
+## # A tibble: 3 × 3
+##   species   emm_mean calculation                   
+##   &lt;fct&gt;        &lt;dbl&gt; &lt;chr&gt;                         
+## 1 Adelie       3706. (3368.8 + 4043.5) / 2 = 3706.2
+## 2 Chinstrap    3733. (3527.2 + 3939) / 2 = 3733.1  
+## 3 Gentoo       5082. (4679.7 + 5484.8) / 2 = 5082.3
+## 
+## 
+## Comparison showing EMM calculation:
+## # A tibble: 3 × 6
+##   species   cell_mean_female cell_mean_male species_emm regular_mean difference
+##   &lt;fct&gt;                &lt;dbl&gt;          &lt;dbl&gt;       &lt;dbl&gt;        &lt;dbl&gt;      &lt;dbl&gt;
+## 1 Adelie               3369.          4043.       3706.        3706.   4.55e-13
+## 2 Chinstrap            3527.          3939.       3733.        3733.   0       
+## 3 Gentoo               4680.          5485.       5082.        5092.  -1.01e+ 1</a:t>
             </a:r>
           </a:p>
         </p:txBody>
@@ -4417,9 +4361,31 @@
               <a:rPr>
                 <a:latin typeface="Courier"/>
               </a:rPr>
-              <a:t>[1] "Combined table with means and counts:"</a:t>
-            </a:r>
-          </a:p>
+              <a:t>## Combined table with means and counts:
+## # A tibble: 3 × 5
+##   species   female_mean male_mean female_n male_n
+##   &lt;fct&gt;           &lt;dbl&gt;     &lt;dbl&gt;    &lt;int&gt;  &lt;int&gt;
+## 1 Adelie          3369.     4043.       73     73
+## 2 Chinstrap       3527.     3939.       34     34
+## 3 Gentoo          4680.     5485.       58     61</a:t>
+            </a:r>
+          </a:p>
+        </p:txBody>
+      </p:sp>
+      <p:sp>
+        <p:nvSpPr>
+          <p:cNvPr id="4" name="Content Placeholder 3"/>
+          <p:cNvSpPr>
+            <a:spLocks noGrp="1"/>
+          </p:cNvSpPr>
+          <p:nvPr>
+            <p:ph idx="2" sz="half"/>
+          </p:nvPr>
+        </p:nvSpPr>
+        <p:spPr/>
+        <p:txBody>
+          <a:bodyPr/>
+          <a:lstStyle/>
           <a:p>
             <a:pPr lvl="0" indent="0">
               <a:buNone/>
@@ -4428,106 +4394,28 @@
               <a:rPr>
                 <a:latin typeface="Courier"/>
               </a:rPr>
-              <a:t># A tibble: 3 × 5
-  species   female_mean male_mean female_n male_n
-  &lt;fct&gt;           &lt;dbl&gt;     &lt;dbl&gt;    &lt;int&gt;  &lt;int&gt;
-1 Adelie          3369.     4043.       73     73
-2 Chinstrap       3527.     3939.       34     34
-3 Gentoo          4680.     5485.       58     61</a:t>
-            </a:r>
-          </a:p>
-        </p:txBody>
-      </p:sp>
-      <p:sp>
-        <p:nvSpPr>
-          <p:cNvPr id="4" name="Content Placeholder 3"/>
-          <p:cNvSpPr>
-            <a:spLocks noGrp="1"/>
-          </p:cNvSpPr>
-          <p:nvPr>
-            <p:ph idx="2" sz="half"/>
-          </p:nvPr>
-        </p:nvSpPr>
-        <p:spPr/>
-        <p:txBody>
-          <a:bodyPr/>
-          <a:lstStyle/>
-          <a:p>
-            <a:pPr lvl="0" indent="0">
-              <a:buNone/>
-            </a:pPr>
-            <a:r>
-              <a:rPr>
-                <a:latin typeface="Courier"/>
-              </a:rPr>
-              <a:t>[1] "\nRegular means sex (WRONG for marginal means):"</a:t>
-            </a:r>
-          </a:p>
-          <a:p>
-            <a:pPr lvl="0" indent="0">
-              <a:buNone/>
-            </a:pPr>
-            <a:r>
-              <a:rPr>
-                <a:latin typeface="Courier"/>
-              </a:rPr>
-              <a:t># A tibble: 2 × 3
-  sex    total_n regular_mean
-  &lt;fct&gt;    &lt;int&gt;        &lt;dbl&gt;
-1 female     165        3862.
-2 male       168        4546.</a:t>
-            </a:r>
-          </a:p>
-          <a:p>
-            <a:pPr lvl="0" indent="0">
-              <a:buNone/>
-            </a:pPr>
-            <a:r>
-              <a:rPr>
-                <a:latin typeface="Courier"/>
-              </a:rPr>
-              <a:t>[1] "\nEstimated Marginal Means for Sex (CORRECT):"</a:t>
-            </a:r>
-          </a:p>
-          <a:p>
-            <a:pPr lvl="0" indent="0">
-              <a:buNone/>
-            </a:pPr>
-            <a:r>
-              <a:rPr>
-                <a:latin typeface="Courier"/>
-              </a:rPr>
-              <a:t># A tibble: 2 × 3
-  sex    emm_mean calculation                            
-  &lt;fct&gt;     &lt;dbl&gt; &lt;chr&gt;                                  
-1 female    3859. (3368.8 + 3527.2 + 4679.7) / 3 = 3858.6
-2 male      4489. (4043.5 + 3939 + 5484.8) / 3 = 4489.1  </a:t>
-            </a:r>
-          </a:p>
-          <a:p>
-            <a:pPr lvl="0" indent="0">
-              <a:buNone/>
-            </a:pPr>
-            <a:r>
-              <a:rPr>
-                <a:latin typeface="Courier"/>
-              </a:rPr>
-              <a:t>[1] "\nComparison showing difference between regular and marginal means:"</a:t>
-            </a:r>
-          </a:p>
-          <a:p>
-            <a:pPr lvl="0" indent="0">
-              <a:buNone/>
-            </a:pPr>
-            <a:r>
-              <a:rPr>
-                <a:latin typeface="Courier"/>
-              </a:rPr>
-              <a:t># A tibble: 2 × 5
-  sex    total_n regular_mean emm_mean difference
-  &lt;fct&gt;    &lt;int&gt;        &lt;dbl&gt;    &lt;dbl&gt;      &lt;dbl&gt;
-1 female     165        3862.    3859.      -3.68
-2 male       168        4546.    4489.     -56.6 </a:t>
+              <a:t>## 
+## Regular means sex (WRONG for marginal means):
+## # A tibble: 2 × 3
+##   sex    total_n regular_mean
+##   &lt;fct&gt;    &lt;int&gt;        &lt;dbl&gt;
+## 1 female     165        3862.
+## 2 male       168        4546.
+## 
+## 
+## Estimated Marginal Means for Sex (CORRECT):
+## # A tibble: 2 × 3
+##   sex    emm_mean calculation                            
+##   &lt;fct&gt;     &lt;dbl&gt; &lt;chr&gt;                                  
+## 1 female    3859. (3368.8 + 3527.2 + 4679.7) / 3 = 3858.6
+## 2 male      4489. (4043.5 + 3939 + 5484.8) / 3 = 4489.1
+## \n
+## Comparison showing difference between regular and marginal means:
+## # A tibble: 2 × 5
+##   sex    total_n regular_mean emm_mean difference
+##   &lt;fct&gt;    &lt;int&gt;        &lt;dbl&gt;    &lt;dbl&gt;      &lt;dbl&gt;
+## 1 female     165        3862.    3859.      -3.68
+## 2 male       168        4546.    4489.     -56.6</a:t>
             </a:r>
           </a:p>
         </p:txBody>
@@ -5804,25 +5692,28 @@
               <a:rPr>
                 <a:latin typeface="Courier"/>
               </a:rPr>
-              <a:t>
-Call:
-lm(formula = body_mass_g ~ species * sex, data = balanced_df)
-Residuals:
-    Min      1Q  Median      3Q     Max 
--827.21 -178.13    6.25  175.00  861.03 
-Coefficients:
-              Estimate Std. Error t value Pr(&gt;|t|)    
-(Intercept)    4175.86      21.23 196.727  &lt; 2e-16 ***
-species1       -484.31      30.02 -16.134  &lt; 2e-16 ***
-species2       -442.77      30.02 -14.750  &lt; 2e-16 ***
-sex1           -328.31      21.23 -15.467  &lt; 2e-16 ***
-species1:sex1   -28.68      30.02  -0.955    0.341    
-species2:sex1   122.43      30.02   4.078 6.57e-05 ***
----
-Signif. codes:  0 '***' 0.001 '**' 0.01 '*' 0.05 '.' 0.1 ' ' 1
-Residual standard error: 303.2 on 198 degrees of freedom
-Multiple R-squared:  0.8596,    Adjusted R-squared:  0.856 
-F-statistic: 242.4 on 5 and 198 DF,  p-value: &lt; 2.2e-16</a:t>
+              <a:t>## 
+## Call:
+## lm(formula = body_mass_g ~ species * sex, data = balanced_df)
+## 
+## Residuals:
+##     Min      1Q  Median      3Q     Max 
+## -827.21 -178.13    6.25  175.00  861.03 
+## 
+## Coefficients:
+##               Estimate Std. Error t value Pr(&gt;|t|)    
+## (Intercept)    4175.86      21.23 196.727  &lt; 2e-16 ***
+## species1       -484.31      30.02 -16.134  &lt; 2e-16 ***
+## species2       -442.77      30.02 -14.750  &lt; 2e-16 ***
+## sex1           -328.31      21.23 -15.467  &lt; 2e-16 ***
+## species1:sex1   -28.68      30.02  -0.955    0.341    
+## species2:sex1   122.43      30.02   4.078 6.57e-05 ***
+## ---
+## Signif. codes:  0 '***' 0.001 '**' 0.01 '*' 0.05 '.' 0.1 ' ' 1
+## 
+## Residual standard error: 303.2 on 198 degrees of freedom
+## Multiple R-squared:  0.8596, Adjusted R-squared:  0.856 
+## F-statistic: 242.4 on 5 and 198 DF,  p-value: &lt; 2.2e-16</a:t>
             </a:r>
           </a:p>
         </p:txBody>
@@ -5849,27 +5740,18 @@
               <a:rPr>
                 <a:latin typeface="Courier"/>
               </a:rPr>
-              <a:t>[1] "Type III Sums of Squares ANOVA:"</a:t>
-            </a:r>
-          </a:p>
-          <a:p>
-            <a:pPr lvl="0" indent="0">
-              <a:buNone/>
-            </a:pPr>
-            <a:r>
-              <a:rPr>
-                <a:latin typeface="Courier"/>
-              </a:rPr>
-              <a:t>Anova Table (Type III tests)
-Response: body_mass_g
-                Sum Sq  Df    F value    Pr(&gt;F)    
-(Intercept) 3557308900   1 38701.5271 &lt; 2.2e-16 ***
-species       87725999   2   477.2049 &lt; 2.2e-16 ***
-sex           21988483   1   239.2224 &lt; 2.2e-16 ***
-species:sex    1672776   2     9.0994 0.0001657 ***
-Residuals     18199467 198                         
----
-Signif. codes:  0 '***' 0.001 '**' 0.01 '*' 0.05 '.' 0.1 ' ' 1</a:t>
+              <a:t>## Type III Sums of Squares ANOVA:
+## Anova Table (Type III tests)
+## 
+## Response: body_mass_g
+##                 Sum Sq  Df    F value    Pr(&gt;F)    
+## (Intercept) 3557308900   1 38701.5271 &lt; 2.2e-16 ***
+## species       87725999   2   477.2049 &lt; 2.2e-16 ***
+## sex           21988483   1   239.2224 &lt; 2.2e-16 ***
+## species:sex    1672776   2     9.0994 0.0001657 ***
+## Residuals     18199467 198                         
+## ---
+## Signif. codes:  0 '***' 0.001 '**' 0.01 '*' 0.05 '.' 0.1 ' ' 1</a:t>
             </a:r>
           </a:p>
         </p:txBody>
@@ -6018,21 +5900,11 @@
               <a:rPr>
                 <a:latin typeface="Courier"/>
               </a:rPr>
-              <a:t>[1] "Effect Sizes (Eta-squared):"</a:t>
-            </a:r>
-          </a:p>
-          <a:p>
-            <a:pPr lvl="0" indent="0">
-              <a:buNone/>
-            </a:pPr>
-            <a:r>
-              <a:rPr>
-                <a:latin typeface="Courier"/>
-              </a:rPr>
-              <a:t>       Effect Eta_Squared
-1     Species  0.67696748
-2         Sex  0.16968160
-3 Interaction  0.01290854</a:t>
+              <a:t>## Effect Sizes (Eta-squared):
+##        Effect Eta_Squared
+## 1     Species  0.67696748
+## 2         Sex  0.16968160
+## 3 Interaction  0.01290854</a:t>
             </a:r>
           </a:p>
         </p:txBody>
@@ -6272,57 +6144,18 @@
               <a:rPr>
                 <a:latin typeface="Courier"/>
               </a:rPr>
-              <a:t>[1] "Shapiro-Wilk Normality Test:"</a:t>
-            </a:r>
-          </a:p>
-          <a:p>
-            <a:pPr lvl="0" indent="0">
-              <a:buNone/>
-            </a:pPr>
-            <a:r>
-              <a:rPr>
-                <a:latin typeface="Courier"/>
-              </a:rPr>
-              <a:t>
-    Shapiro-Wilk normality test
-data:  residuals(anova_model)
-W = 0.99612, p-value = 0.8886</a:t>
-            </a:r>
-          </a:p>
-          <a:p>
-            <a:pPr lvl="0" indent="0">
-              <a:buNone/>
-            </a:pPr>
-            <a:r>
-              <a:rPr>
-                <a:latin typeface="Courier"/>
-              </a:rPr>
-              <a:t>[1] "Levene's Test for Homogeneity:"</a:t>
-            </a:r>
-          </a:p>
-          <a:p>
-            <a:pPr lvl="0" indent="0">
-              <a:buNone/>
-            </a:pPr>
-            <a:r>
-              <a:rPr>
-                <a:latin typeface="Courier"/>
-              </a:rPr>
-              <a:t>Levene's Test for Homogeneity of Variance (center = median)
-       Df F value Pr(&gt;F)
-group   5  0.7841 0.5622
-      198               </a:t>
-            </a:r>
-          </a:p>
-          <a:p>
-            <a:pPr lvl="0" indent="0">
-              <a:buNone/>
-            </a:pPr>
-            <a:r>
-              <a:rPr>
-                <a:latin typeface="Courier"/>
-              </a:rPr>
-              <a:t>[1] "Number of outliers (|z| &gt; 3): 0"</a:t>
+              <a:t>## Shapiro-Wilk Normality Test:
+## 
+##  Shapiro-Wilk normality test
+## 
+## data:  residuals(anova_model)
+## W = 0.99612, p-value = 0.8886
+## Levene's Test for Homogeneity:
+## Levene's Test for Homogeneity of Variance (center = median)
+##        Df F value Pr(&gt;F)
+## group   5  0.7841 0.5622
+##       198
+## Number of outliers (|z| &gt; 3): 0</a:t>
             </a:r>
           </a:p>
         </p:txBody>
@@ -6599,78 +6432,31 @@
               <a:rPr>
                 <a:latin typeface="Courier"/>
               </a:rPr>
-              <a:t>Species EMMs:</a:t>
-            </a:r>
-          </a:p>
-          <a:p>
-            <a:pPr lvl="0" indent="0">
-              <a:buNone/>
-            </a:pPr>
-            <a:r>
-              <a:rPr>
-                <a:latin typeface="Courier"/>
-              </a:rPr>
-              <a:t> species   emmean   SE  df lower.CL upper.CL
- Adelie      3692 36.8 198     3619     3764
- Chinstrap   3733 36.8 198     3661     3806
- Gentoo      5103 36.8 198     5030     5175
-Results are averaged over the levels of: sex 
-Confidence level used: 0.95 </a:t>
-            </a:r>
-          </a:p>
-          <a:p>
-            <a:pPr lvl="0" indent="0">
-              <a:buNone/>
-            </a:pPr>
-            <a:r>
-              <a:rPr>
-                <a:latin typeface="Courier"/>
-              </a:rPr>
-              <a:t>Sex EMMs:</a:t>
-            </a:r>
-          </a:p>
-          <a:p>
-            <a:pPr lvl="0" indent="0">
-              <a:buNone/>
-            </a:pPr>
-            <a:r>
-              <a:rPr>
-                <a:latin typeface="Courier"/>
-              </a:rPr>
-              <a:t> sex    emmean SE  df lower.CL upper.CL
- female   3848 30 198     3788     3907
- male     4504 30 198     4445     4563
-Results are averaged over the levels of: species 
-Confidence level used: 0.95 </a:t>
-            </a:r>
-          </a:p>
-          <a:p>
-            <a:pPr lvl="0" indent="0">
-              <a:buNone/>
-            </a:pPr>
-            <a:r>
-              <a:rPr>
-                <a:latin typeface="Courier"/>
-              </a:rPr>
-              <a:t>Species by Sex EMMs:</a:t>
-            </a:r>
-          </a:p>
-          <a:p>
-            <a:pPr lvl="0" indent="0">
-              <a:buNone/>
-            </a:pPr>
-            <a:r>
-              <a:rPr>
-                <a:latin typeface="Courier"/>
-              </a:rPr>
-              <a:t> species   sex    emmean SE  df lower.CL upper.CL
- Adelie    female   3335 52 198     3232     3437
- Chinstrap female   3527 52 198     3425     3630
- Gentoo    female   4681 52 198     4578     4783
- Adelie    male     4049 52 198     3946     4151
- Chinstrap male     3939 52 198     3836     4042
- Gentoo    male     5525 52 198     5422     5628
-Confidence level used: 0.95 </a:t>
+              <a:t>## Species EMMs:
+##  species   emmean   SE  df lower.CL upper.CL
+##  Adelie      3692 36.8 198     3619     3764
+##  Chinstrap   3733 36.8 198     3661     3806
+##  Gentoo      5103 36.8 198     5030     5175
+## 
+## Results are averaged over the levels of: sex 
+## Confidence level used: 0.95
+## Sex EMMs:
+##  sex    emmean SE  df lower.CL upper.CL
+##  female   3848 30 198     3788     3907
+##  male     4504 30 198     4445     4563
+## 
+## Results are averaged over the levels of: species 
+## Confidence level used: 0.95
+## Species by Sex EMMs:
+##  species   sex    emmean SE  df lower.CL upper.CL
+##  Adelie    female   3335 52 198     3232     3437
+##  Chinstrap female   3527 52 198     3425     3630
+##  Gentoo    female   4681 52 198     4578     4783
+##  Adelie    male     4049 52 198     3946     4151
+##  Chinstrap male     3939 52 198     3836     4042
+##  Gentoo    male     5525 52 198     5422     5628
+## 
+## Confidence level used: 0.95</a:t>
             </a:r>
           </a:p>
         </p:txBody>
@@ -6709,55 +6495,28 @@
               <a:rPr>
                 <a:latin typeface="Courier"/>
               </a:rPr>
-              <a:t>[1] "Species pairwise comparisons:"</a:t>
-            </a:r>
-          </a:p>
-          <a:p>
-            <a:pPr lvl="0" indent="0">
-              <a:buNone/>
-            </a:pPr>
-            <a:r>
-              <a:rPr>
-                <a:latin typeface="Courier"/>
-              </a:rPr>
-              <a:t> contrast           estimate SE  df t.ratio p.value
- Adelie - Chinstrap    -41.5 52 198  -0.799  0.7041
- Adelie - Gentoo     -1411.4 52 198 -27.145  &lt;.0001
- Chinstrap - Gentoo  -1369.9 52 198 -26.346  &lt;.0001
-Results are averaged over the levels of: sex 
-P value adjustment: tukey method for comparing a family of 3 estimates </a:t>
-            </a:r>
-          </a:p>
-          <a:p>
-            <a:pPr lvl="0" indent="0">
-              <a:buNone/>
-            </a:pPr>
-            <a:r>
-              <a:rPr>
-                <a:latin typeface="Courier"/>
-              </a:rPr>
-              <a:t>[1] "Species comparisons within sex:"</a:t>
-            </a:r>
-          </a:p>
-          <a:p>
-            <a:pPr lvl="0" indent="0">
-              <a:buNone/>
-            </a:pPr>
-            <a:r>
-              <a:rPr>
-                <a:latin typeface="Courier"/>
-              </a:rPr>
-              <a:t>sex = female:
- contrast           estimate   SE  df t.ratio p.value
- Adelie - Chinstrap     -193 73.5 198  -2.620  0.0256
- Adelie - Gentoo       -1346 73.5 198 -18.310  &lt;.0001
- Chinstrap - Gentoo    -1154 73.5 198 -15.690  &lt;.0001
-sex = male:
- contrast           estimate   SE  df t.ratio p.value
- Adelie - Chinstrap      110 73.5 198   1.490  0.2979
- Adelie - Gentoo       -1476 73.5 198 -20.079  &lt;.0001
- Chinstrap - Gentoo    -1586 73.5 198 -21.569  &lt;.0001
-P value adjustment: tukey method for comparing a family of 3 estimates </a:t>
+              <a:t>## [1] "Species pairwise comparisons:\n"
+##  contrast           estimate SE  df t.ratio p.value
+##  Adelie - Chinstrap    -41.5 52 198  -0.799  0.7041
+##  Adelie - Gentoo     -1411.4 52 198 -27.145  &lt;.0001
+##  Chinstrap - Gentoo  -1369.9 52 198 -26.346  &lt;.0001
+## 
+## Results are averaged over the levels of: sex 
+## P value adjustment: tukey method for comparing a family of 3 estimates
+## [1] "Species comparisons within sex:"
+## sex = female:
+##  contrast           estimate   SE  df t.ratio p.value
+##  Adelie - Chinstrap     -193 73.5 198  -2.620  0.0256
+##  Adelie - Gentoo       -1346 73.5 198 -18.310  &lt;.0001
+##  Chinstrap - Gentoo    -1154 73.5 198 -15.690  &lt;.0001
+## 
+## sex = male:
+##  contrast           estimate   SE  df t.ratio p.value
+##  Adelie - Chinstrap      110 73.5 198   1.490  0.2979
+##  Adelie - Gentoo       -1476 73.5 198 -20.079  &lt;.0001
+##  Chinstrap - Gentoo    -1586 73.5 198 -21.569  &lt;.0001
+## 
+## P value adjustment: tukey method for comparing a family of 3 estimates</a:t>
             </a:r>
           </a:p>
         </p:txBody>
@@ -6913,20 +6672,21 @@
               <a:rPr>
                 <a:latin typeface="Courier"/>
               </a:rPr>
-              <a:t> species   sex      emmean       SE  df lower.CL upper.CL .group
- Adelie    female 3334.559 51.99448 198 3196.378 3472.740  a    
- Adelie    male   4048.529 51.99448 198 3910.349 4186.710   b   
- Chinstrap female 3527.206 51.99448 198 3389.025 3665.387  a    
- Chinstrap male   3938.971 51.99448 198 3800.790 4077.151   b   
- Gentoo    female 4680.882 51.99448 198 4542.702 4819.063    c  
- Gentoo    male   5525.000 51.99448 198 5386.819 5663.181     d 
-Confidence level used: 0.95 
-Conf-level adjustment: sidak method for 6 estimates 
-P value adjustment: sidak method for 15 tests 
-significance level used: alpha = 0.05 
-NOTE: If two or more means share the same grouping symbol,
-      then we cannot show them to be different.
-      But we also did not show them to be the same. </a:t>
+              <a:t>##  species   sex      emmean       SE  df lower.CL upper.CL .group
+##  Adelie    female 3334.559 51.99448 198 3196.378 3472.740  a    
+##  Adelie    male   4048.529 51.99448 198 3910.349 4186.710   b   
+##  Chinstrap female 3527.206 51.99448 198 3389.025 3665.387  a    
+##  Chinstrap male   3938.971 51.99448 198 3800.790 4077.151   b   
+##  Gentoo    female 4680.882 51.99448 198 4542.702 4819.063    c  
+##  Gentoo    male   5525.000 51.99448 198 5386.819 5663.181     d 
+## 
+## Confidence level used: 0.95 
+## Conf-level adjustment: sidak method for 6 estimates 
+## P value adjustment: sidak method for 15 tests 
+## significance level used: alpha = 0.05 
+## NOTE: If two or more means share the same grouping symbol,
+##       then we cannot show them to be different.
+##       But we also did not show them to be the same.</a:t>
             </a:r>
           </a:p>
         </p:txBody>
@@ -6983,36 +6743,27 @@
           </a:p>
         </p:txBody>
       </p:sp>
-      <p:pic>
-        <p:nvPicPr>
-          <p:cNvPr descr="12_01_lecture_powerpoint_files/figure-pptx/interaction_plot-1.png" id="0" name="Picture 1"/>
-          <p:cNvPicPr>
-            <a:picLocks noGrp="1" noChangeAspect="1"/>
-          </p:cNvPicPr>
-          <p:nvPr/>
-        </p:nvPicPr>
-        <p:blipFill>
-          <a:blip r:embed="rId2"/>
-          <a:stretch>
-            <a:fillRect/>
-          </a:stretch>
-        </p:blipFill>
-        <p:spPr bwMode="auto">
-          <a:xfrm>
-            <a:off x="1358900" y="609600"/>
-            <a:ext cx="6350000" cy="3911600"/>
-          </a:xfrm>
-          <a:prstGeom prst="rect">
-            <a:avLst/>
-          </a:prstGeom>
-          <a:noFill/>
-          <a:ln w="9525">
-            <a:noFill/>
-            <a:headEnd/>
-            <a:tailEnd/>
-          </a:ln>
-        </p:spPr>
-      </p:pic>
+      <p:sp>
+        <p:nvSpPr>
+          <p:cNvPr id="3" name="Content Placeholder 2"/>
+          <p:cNvSpPr>
+            <a:spLocks noGrp="1"/>
+          </p:cNvSpPr>
+          <p:nvPr>
+            <p:ph idx="1"/>
+          </p:nvPr>
+        </p:nvSpPr>
+        <p:spPr/>
+        <p:txBody>
+          <a:bodyPr/>
+          <a:lstStyle/>
+          <a:p>
+            <a:pPr lvl="0" indent="0" marL="0">
+              <a:buNone/>
+            </a:pPr>
+          </a:p>
+        </p:txBody>
+      </p:sp>
     </p:spTree>
   </p:cSld>
 </p:sld>
@@ -7319,48 +7070,18 @@
                   <a:rPr>
                     <a:latin typeface="Courier"/>
                   </a:rPr>
-                  <a:t>[1] "Unbalanced sample sizes:"</a:t>
-                </a:r>
-              </a:p>
-              <a:p>
-                <a:pPr lvl="0" indent="0">
-                  <a:buNone/>
-                </a:pPr>
-                <a:r>
-                  <a:rPr>
-                    <a:latin typeface="Courier"/>
-                  </a:rPr>
-                  <a:t># A tibble: 6 × 3
-  species   sex        n
-  &lt;fct&gt;     &lt;fct&gt;  &lt;int&gt;
-1 Adelie    female    73
-2 Adelie    male      73
-3 Chinstrap female    34
-4 Chinstrap male      34
-5 Gentoo    female    58
-6 Gentoo    male      61</a:t>
-                </a:r>
-              </a:p>
-              <a:p>
-                <a:pPr lvl="0" indent="0">
-                  <a:buNone/>
-                </a:pPr>
-                <a:r>
-                  <a:rPr>
-                    <a:latin typeface="Courier"/>
-                  </a:rPr>
-                  <a:t>[1] "Total N = 333"</a:t>
-                </a:r>
-              </a:p>
-              <a:p>
-                <a:pPr lvl="0" indent="0">
-                  <a:buNone/>
-                </a:pPr>
-                <a:r>
-                  <a:rPr>
-                    <a:latin typeface="Courier"/>
-                  </a:rPr>
-                  <a:t>[1] "Imbalance ratio = 2.15"</a:t>
+                  <a:t>## [1] "Unbalanced sample sizes:"
+## # A tibble: 6 × 3
+##   species   sex        n
+##   &lt;fct&gt;     &lt;fct&gt;  &lt;int&gt;
+## 1 Adelie    female    73
+## 2 Adelie    male      73
+## 3 Chinstrap female    34
+## 4 Chinstrap male      34
+## 5 Gentoo    female    58
+## 6 Gentoo    male      61
+## [1] "Total N = 333"
+## [1] "Imbalance ratio = 2.15"</a:t>
                 </a:r>
               </a:p>
             </p:txBody>
@@ -7514,80 +7235,36 @@
               <a:rPr>
                 <a:latin typeface="Courier"/>
               </a:rPr>
-              <a:t>[1] "Type I SS (Species → Sex → Interaction):"</a:t>
-            </a:r>
-          </a:p>
-          <a:p>
-            <a:pPr lvl="0" indent="0">
-              <a:buNone/>
-            </a:pPr>
-            <a:r>
-              <a:rPr>
-                <a:latin typeface="Courier"/>
-              </a:rPr>
-              <a:t>Analysis of Variance Table
-Response: body_mass_g
-             Df    Sum Sq  Mean Sq F value    Pr(&gt;F)    
-species       2 145190219 72595110 758.358 &lt; 2.2e-16 ***
-sex           1  37090262 37090262 387.460 &lt; 2.2e-16 ***
-species:sex   2   1676557   838278   8.757 0.0001973 ***
-Residuals   327  31302628    95727                      
----
-Signif. codes:  0 '***' 0.001 '**' 0.01 '*' 0.05 '.' 0.1 ' ' 1</a:t>
-            </a:r>
-          </a:p>
-          <a:p>
-            <a:pPr lvl="0" indent="0">
-              <a:buNone/>
-            </a:pPr>
-            <a:r>
-              <a:rPr>
-                <a:latin typeface="Courier"/>
-              </a:rPr>
-              <a:t>[1] "Type I SS (Sex → Species → Interaction):"</a:t>
-            </a:r>
-          </a:p>
-          <a:p>
-            <a:pPr lvl="0" indent="0">
-              <a:buNone/>
-            </a:pPr>
-            <a:r>
-              <a:rPr>
-                <a:latin typeface="Courier"/>
-              </a:rPr>
-              <a:t>Analysis of Variance Table
-Response: body_mass_g
-             Df    Sum Sq  Mean Sq F value    Pr(&gt;F)    
-sex           1  38878897 38878897 406.145 &lt; 2.2e-16 ***
-species       2 143401584 71700792 749.016 &lt; 2.2e-16 ***
-sex:species   2   1676557   838278   8.757 0.0001973 ***
-Residuals   327  31302628    95727                      
----
-Signif. codes:  0 '***' 0.001 '**' 0.01 '*' 0.05 '.' 0.1 ' ' 1</a:t>
-            </a:r>
-          </a:p>
-          <a:p>
-            <a:pPr lvl="0" indent="0">
-              <a:buNone/>
-            </a:pPr>
-            <a:r>
-              <a:rPr>
-                <a:latin typeface="Courier"/>
-              </a:rPr>
-              <a:t>[1] "Type I SS depends on order:"</a:t>
-            </a:r>
-          </a:p>
-          <a:p>
-            <a:pPr lvl="0" indent="0">
-              <a:buNone/>
-            </a:pPr>
-            <a:r>
-              <a:rPr>
-                <a:latin typeface="Courier"/>
-              </a:rPr>
-              <a:t>   Effect Order1_SS Order2_SS
-1 Species 145190219 143401584
-2     Sex  37090262  38878897</a:t>
+              <a:t>## Type I SS (Species → Sex → Interaction):
+## Analysis of Variance Table
+## 
+## Response: body_mass_g
+##              Df    Sum Sq  Mean Sq F value    Pr(&gt;F)    
+## species       2 145190219 72595110 758.358 &lt; 2.2e-16 ***
+## sex           1  37090262 37090262 387.460 &lt; 2.2e-16 ***
+## species:sex   2   1676557   838278   8.757 0.0001973 ***
+## Residuals   327  31302628    95727                      
+## ---
+## Signif. codes:  0 '***' 0.001 '**' 0.01 '*' 0.05 '.' 0.1 ' ' 1
+## 
+## 
+## Type I SS (Sex → Species → Interaction):
+## Analysis of Variance Table
+## 
+## Response: body_mass_g
+##              Df    Sum Sq  Mean Sq F value    Pr(&gt;F)    
+## sex           1  38878897 38878897 406.145 &lt; 2.2e-16 ***
+## species       2 143401584 71700792 749.016 &lt; 2.2e-16 ***
+## sex:species   2   1676557   838278   8.757 0.0001973 ***
+## Residuals   327  31302628    95727                      
+## ---
+## Signif. codes:  0 '***' 0.001 '**' 0.01 '*' 0.05 '.' 0.1 ' ' 1
+## 
+## 
+## Type I SS depends on order:
+##    Effect Order1_SS Order2_SS
+## 1 Species 145190219 143401584
+## 2     Sex  37090262  38878897</a:t>
             </a:r>
           </a:p>
         </p:txBody>
@@ -7813,52 +7490,23 @@
               <a:rPr>
                 <a:latin typeface="Courier"/>
               </a:rPr>
-              <a:t>[1] "Type III Sums of Squares:"</a:t>
-            </a:r>
-          </a:p>
-          <a:p>
-            <a:pPr lvl="0" indent="0">
-              <a:buNone/>
-            </a:pPr>
-            <a:r>
-              <a:rPr>
-                <a:latin typeface="Courier"/>
-              </a:rPr>
-              <a:t>Anova Table (Type III tests)
-Response: body_mass_g
-                Sum Sq  Df   F value    Pr(&gt;F)    
-(Intercept) 5232595969   1 54661.828 &lt; 2.2e-16 ***
-species      143001222   2   746.924 &lt; 2.2e-16 ***
-sex           29851220   1   311.838 &lt; 2.2e-16 ***
-species:sex    1676557   2     8.757 0.0001973 ***
-Residuals     31302628 327                        
----
-Signif. codes:  0 '***' 0.001 '**' 0.01 '*' 0.05 '.' 0.1 ' ' 1</a:t>
-            </a:r>
-          </a:p>
-          <a:p>
-            <a:pPr lvl="0" indent="0">
-              <a:buNone/>
-            </a:pPr>
-            <a:r>
-              <a:rPr>
-                <a:latin typeface="Courier"/>
-              </a:rPr>
-              <a:t>[1] "Comparison of F-values:"</a:t>
-            </a:r>
-          </a:p>
-          <a:p>
-            <a:pPr lvl="0" indent="0">
-              <a:buNone/>
-            </a:pPr>
-            <a:r>
-              <a:rPr>
-                <a:latin typeface="Courier"/>
-              </a:rPr>
-              <a:t>       Effect Type_I_F Type_III_F
-1     Species   758.36     746.92
-2         Sex   387.46     311.84
-3 Interaction     8.76       8.76</a:t>
+              <a:t>## [1] "Type III Sums of Squares:"
+## Anova Table (Type III tests)
+## 
+## Response: body_mass_g
+##                 Sum Sq  Df   F value    Pr(&gt;F)    
+## (Intercept) 5232595969   1 54661.828 &lt; 2.2e-16 ***
+## species      143001222   2   746.924 &lt; 2.2e-16 ***
+## sex           29851220   1   311.838 &lt; 2.2e-16 ***
+## species:sex    1676557   2     8.757 0.0001973 ***
+## Residuals     31302628 327                        
+## ---
+## Signif. codes:  0 '***' 0.001 '**' 0.01 '*' 0.05 '.' 0.1 ' ' 1
+## [1] "Comparison of F-values:"
+##        Effect Type_I_F Type_III_F
+## 1     Species   758.36     746.92
+## 2         Sex   387.46     311.84
+## 3 Interaction     8.76       8.76</a:t>
             </a:r>
           </a:p>
         </p:txBody>
@@ -7988,21 +7636,11 @@
               <a:rPr>
                 <a:latin typeface="Courier"/>
               </a:rPr>
-              <a:t>[1] "Effect Sizes (Type III):"</a:t>
-            </a:r>
-          </a:p>
-          <a:p>
-            <a:pPr lvl="0" indent="0">
-              <a:buNone/>
-            </a:pPr>
-            <a:r>
-              <a:rPr>
-                <a:latin typeface="Courier"/>
-              </a:rPr>
-              <a:t>       Effect Eta_Squared
-1     Species      0.6947
-2         Sex      0.1450
-3 Interaction      0.0081</a:t>
+              <a:t>## [1] "Effect Sizes (Type III):"
+##        Effect Eta_Squared
+## 1     Species      0.6947
+## 2         Sex      0.1450
+## 3 Interaction      0.0081</a:t>
             </a:r>
           </a:p>
         </p:txBody>
@@ -8096,51 +7734,11 @@
               <a:rPr>
                 <a:latin typeface="Courier"/>
               </a:rPr>
-              <a:t>[1] "Grand mean: 4207.1"</a:t>
-            </a:r>
-          </a:p>
-          <a:p>
-            <a:pPr lvl="0" indent="0">
-              <a:buNone/>
-            </a:pPr>
-            <a:r>
-              <a:rPr>
-                <a:latin typeface="Courier"/>
-              </a:rPr>
-              <a:t>[1] "Total SS: 215259666"</a:t>
-            </a:r>
-          </a:p>
-          <a:p>
-            <a:pPr lvl="0" indent="0">
-              <a:buNone/>
-            </a:pPr>
-            <a:r>
-              <a:rPr>
-                <a:latin typeface="Courier"/>
-              </a:rPr>
-              <a:t>[1] "Between-groups SS: 183957038"</a:t>
-            </a:r>
-          </a:p>
-          <a:p>
-            <a:pPr lvl="0" indent="0">
-              <a:buNone/>
-            </a:pPr>
-            <a:r>
-              <a:rPr>
-                <a:latin typeface="Courier"/>
-              </a:rPr>
-              <a:t>[1] "Within-groups SS: 31302628"</a:t>
-            </a:r>
-          </a:p>
-          <a:p>
-            <a:pPr lvl="0" indent="0">
-              <a:buNone/>
-            </a:pPr>
-            <a:r>
-              <a:rPr>
-                <a:latin typeface="Courier"/>
-              </a:rPr>
-              <a:t>[1] "Check: Between + Within = 215259666"</a:t>
+              <a:t>## [1] "Grand mean: 4207.1"
+## [1] "Total SS: 215259666"
+## [1] "Between-groups SS: 183957038"
+## [1] "Within-groups SS: 31302628"
+## [1] "Check: Between + Within = 215259666"</a:t>
             </a:r>
           </a:p>
         </p:txBody>
@@ -8179,51 +7777,15 @@
               <a:rPr>
                 <a:latin typeface="Courier"/>
               </a:rPr>
-              <a:t>[1] "SS(Species alone): 145190219"</a:t>
-            </a:r>
-          </a:p>
-          <a:p>
-            <a:pPr lvl="0" indent="0">
-              <a:buNone/>
-            </a:pPr>
-            <a:r>
-              <a:rPr>
-                <a:latin typeface="Courier"/>
-              </a:rPr>
-              <a:t>[1] "SS(Sex alone): 38878897"</a:t>
-            </a:r>
-          </a:p>
-          <a:p>
-            <a:pPr lvl="0" indent="0">
-              <a:buNone/>
-            </a:pPr>
-            <a:r>
-              <a:rPr>
-                <a:latin typeface="Courier"/>
-              </a:rPr>
-              <a:t>[1] "Sum of main effects: 184069116"</a:t>
-            </a:r>
-          </a:p>
-          <a:p>
-            <a:pPr lvl="0" indent="0">
-              <a:buNone/>
-            </a:pPr>
-            <a:r>
-              <a:rPr>
-                <a:latin typeface="Courier"/>
-              </a:rPr>
-              <a:t>[1] "Actual between SS: 183957038"</a:t>
-            </a:r>
-          </a:p>
-          <a:p>
-            <a:pPr lvl="0" indent="0">
-              <a:buNone/>
-            </a:pPr>
-            <a:r>
-              <a:rPr>
-                <a:latin typeface="Courier"/>
-              </a:rPr>
-              <a:t>[1] "Difference (due to correlation): -112078"</a:t>
+              <a:t>## SS(Species alone): 145190219
+## SS(Sex alone): 38878897
+## 
+## 
+## Sum of main effects: 184069116
+## Actual between SS: 183957038
+## 
+## 
+## Difference (due to correlation): -112078</a:t>
             </a:r>
           </a:p>
         </p:txBody>
@@ -8314,76 +7876,41 @@
               <a:rPr>
                 <a:latin typeface="Courier"/>
               </a:rPr>
-              <a:t>[1] "Species EMMs (model-based):"</a:t>
-            </a:r>
-          </a:p>
-          <a:p>
-            <a:pPr lvl="0" indent="0">
-              <a:buNone/>
-            </a:pPr>
-            <a:r>
-              <a:rPr>
-                <a:latin typeface="Courier"/>
-              </a:rPr>
-              <a:t> species   emmean   SE  df lower.CL upper.CL
- Adelie      3706 25.6 327     3656     3757
- Chinstrap   3733 37.5 327     3659     3807
- Gentoo      5082 28.4 327     5026     5138
-Results are averaged over the levels of: sex 
-Confidence level used: 0.95 </a:t>
-            </a:r>
-          </a:p>
-          <a:p>
-            <a:pPr lvl="0" indent="0">
-              <a:buNone/>
-            </a:pPr>
-            <a:r>
-              <a:rPr>
-                <a:latin typeface="Courier"/>
-              </a:rPr>
-              <a:t>[1] "\nSex EMMs (model-based):"</a:t>
-            </a:r>
-          </a:p>
-          <a:p>
-            <a:pPr lvl="0" indent="0">
-              <a:buNone/>
-            </a:pPr>
-            <a:r>
-              <a:rPr>
-                <a:latin typeface="Courier"/>
-              </a:rPr>
-              <a:t> sex    emmean   SE  df lower.CL upper.CL
- female   3859 25.3 327     3809     3908
- male     4489 25.2 327     4440     4539
-Results are averaged over the levels of: species 
-Confidence level used: 0.95 </a:t>
-            </a:r>
-          </a:p>
-          <a:p>
-            <a:pPr lvl="0" indent="0">
-              <a:buNone/>
-            </a:pPr>
-            <a:r>
-              <a:rPr>
-                <a:latin typeface="Courier"/>
-              </a:rPr>
-              <a:t> contrast                          estimate   SE  df t.ratio p.value
- Adelie female - Chinstrap female      -193 73.5 198  -2.620  0.0973
- Adelie female - Gentoo female        -1346 73.5 198 -18.310  &lt;.0001
- Adelie female - Adelie male           -714 73.5 198  -9.710  &lt;.0001
- Adelie female - Chinstrap male        -604 73.5 198  -8.220  &lt;.0001
- Adelie female - Gentoo male          -2190 73.5 198 -29.789  &lt;.0001
- Chinstrap female - Gentoo female     -1154 73.5 198 -15.690  &lt;.0001
- Chinstrap female - Adelie male        -521 73.5 198  -7.090  &lt;.0001
- Chinstrap female - Chinstrap male     -412 73.5 198  -5.600  &lt;.0001
- Chinstrap female - Gentoo male       -1998 73.5 198 -27.169  &lt;.0001
- Gentoo female - Adelie male            632 73.5 198   8.600  &lt;.0001
- Gentoo female - Chinstrap male         742 73.5 198  10.090  &lt;.0001
- Gentoo female - Gentoo male           -844 73.5 198 -11.480  &lt;.0001
- Adelie male - Chinstrap male           110 73.5 198   1.490  0.6711
- Adelie male - Gentoo male            -1476 73.5 198 -20.079  &lt;.0001
- Chinstrap male - Gentoo male         -1586 73.5 198 -21.569  &lt;.0001
-P value adjustment: tukey method for comparing a family of 6 estimates </a:t>
+              <a:t>## Species EMMs (model-based):
+##  species   emmean   SE  df lower.CL upper.CL
+##  Adelie      3706 25.6 327     3656     3757
+##  Chinstrap   3733 37.5 327     3659     3807
+##  Gentoo      5082 28.4 327     5026     5138
+## 
+## Results are averaged over the levels of: sex 
+## Confidence level used: 0.95
+## 
+## 
+## Sex EMMs (model-based):
+##  sex    emmean   SE  df lower.CL upper.CL
+##  female   3859 25.3 327     3809     3908
+##  male     4489 25.2 327     4440     4539
+## 
+## Results are averaged over the levels of: species 
+## Confidence level used: 0.95
+##  contrast                          estimate   SE  df t.ratio p.value
+##  Adelie female - Chinstrap female      -193 73.5 198  -2.620  0.0973
+##  Adelie female - Gentoo female        -1346 73.5 198 -18.310  &lt;.0001
+##  Adelie female - Adelie male           -714 73.5 198  -9.710  &lt;.0001
+##  Adelie female - Chinstrap male        -604 73.5 198  -8.220  &lt;.0001
+##  Adelie female - Gentoo male          -2190 73.5 198 -29.789  &lt;.0001
+##  Chinstrap female - Gentoo female     -1154 73.5 198 -15.690  &lt;.0001
+##  Chinstrap female - Adelie male        -521 73.5 198  -7.090  &lt;.0001
+##  Chinstrap female - Chinstrap male     -412 73.5 198  -5.600  &lt;.0001
+##  Chinstrap female - Gentoo male       -1998 73.5 198 -27.169  &lt;.0001
+##  Gentoo female - Adelie male            632 73.5 198   8.600  &lt;.0001
+##  Gentoo female - Chinstrap male         742 73.5 198  10.090  &lt;.0001
+##  Gentoo female - Gentoo male           -844 73.5 198 -11.480  &lt;.0001
+##  Adelie male - Chinstrap male           110 73.5 198   1.490  0.6711
+##  Adelie male - Gentoo male            -1476 73.5 198 -20.079  &lt;.0001
+##  Chinstrap male - Gentoo male         -1586 73.5 198 -21.569  &lt;.0001
+## 
+## P value adjustment: tukey method for comparing a family of 6 estimates</a:t>
             </a:r>
           </a:p>
         </p:txBody>
@@ -8462,20 +7989,21 @@
               <a:rPr>
                 <a:latin typeface="Courier"/>
               </a:rPr>
-              <a:t> species   sex      emmean       SE  df lower.CL upper.CL .group
- Adelie    female 3368.836 36.21222 327 3272.980 3464.692  a    
- Adelie    male   4043.493 36.21222 327 3947.637 4139.349   b   
- Chinstrap female 3527.206 53.06120 327 3386.749 3667.662  a    
- Chinstrap male   3938.971 53.06120 327 3798.514 4079.427   b   
- Gentoo    female 4679.741 40.62586 327 4572.202 4787.281    c  
- Gentoo    male   5484.836 39.61427 327 5379.975 5589.698     d 
-Confidence level used: 0.95 
-Conf-level adjustment: sidak method for 6 estimates 
-P value adjustment: sidak method for 15 tests 
-significance level used: alpha = 0.05 
-NOTE: If two or more means share the same grouping symbol,
-      then we cannot show them to be different.
-      But we also did not show them to be the same. </a:t>
+              <a:t>##  species   sex      emmean       SE  df lower.CL upper.CL .group
+##  Adelie    female 3368.836 36.21222 327 3272.980 3464.692  a    
+##  Adelie    male   4043.493 36.21222 327 3947.637 4139.349   b   
+##  Chinstrap female 3527.206 53.06120 327 3386.749 3667.662  a    
+##  Chinstrap male   3938.971 53.06120 327 3798.514 4079.427   b   
+##  Gentoo    female 4679.741 40.62586 327 4572.202 4787.281    c  
+##  Gentoo    male   5484.836 39.61427 327 5379.975 5589.698     d 
+## 
+## Confidence level used: 0.95 
+## Conf-level adjustment: sidak method for 6 estimates 
+## P value adjustment: sidak method for 15 tests 
+## significance level used: alpha = 0.05 
+## NOTE: If two or more means share the same grouping symbol,
+##       then we cannot show them to be different.
+##       But we also did not show them to be the same.</a:t>
             </a:r>
           </a:p>
         </p:txBody>
@@ -8702,53 +8230,28 @@
               <a:rPr>
                 <a:latin typeface="Courier"/>
               </a:rPr>
-              <a:t>[1] "Species pairwise comparisons (Tukey):"</a:t>
-            </a:r>
-          </a:p>
-          <a:p>
-            <a:pPr lvl="0" indent="0">
-              <a:buNone/>
-            </a:pPr>
-            <a:r>
-              <a:rPr>
-                <a:latin typeface="Courier"/>
-              </a:rPr>
-              <a:t> contrast           estimate   SE  df t.ratio p.value
- Adelie - Chinstrap    -26.9 45.4 327  -0.593  0.8241
- Adelie - Gentoo     -1376.1 38.2 327 -36.007  &lt;.0001
- Chinstrap - Gentoo  -1349.2 47.0 327 -28.682  &lt;.0001
-Results are averaged over the levels of: sex 
-P value adjustment: tukey method for comparing a family of 3 estimates </a:t>
-            </a:r>
-          </a:p>
-          <a:p>
-            <a:pPr lvl="0" indent="0">
-              <a:buNone/>
-            </a:pPr>
-            <a:r>
-              <a:rPr>
-                <a:latin typeface="Courier"/>
-              </a:rPr>
-              <a:t>[1] "\nSex effect within each species:"</a:t>
-            </a:r>
-          </a:p>
-          <a:p>
-            <a:pPr lvl="0" indent="0">
-              <a:buNone/>
-            </a:pPr>
-            <a:r>
-              <a:rPr>
-                <a:latin typeface="Courier"/>
-              </a:rPr>
-              <a:t>species = Adelie:
- contrast      estimate   SE  df t.ratio p.value
- female - male     -675 51.2 327 -13.174  &lt;.0001
-species = Chinstrap:
- contrast      estimate   SE  df t.ratio p.value
- female - male     -412 75.0 327  -5.487  &lt;.0001
-species = Gentoo:
- contrast      estimate   SE  df t.ratio p.value
- female - male     -805 56.7 327 -14.188  &lt;.0001</a:t>
+              <a:t>## Species pairwise comparisons (Tukey):
+##  contrast           estimate   SE  df t.ratio p.value
+##  Adelie - Chinstrap    -26.9 45.4 327  -0.593  0.8241
+##  Adelie - Gentoo     -1376.1 38.2 327 -36.007  &lt;.0001
+##  Chinstrap - Gentoo  -1349.2 47.0 327 -28.682  &lt;.0001
+## 
+## Results are averaged over the levels of: sex 
+## P value adjustment: tukey method for comparing a family of 3 estimates
+## 
+## 
+## Sex effect within each species:
+## species = Adelie:
+##  contrast      estimate   SE  df t.ratio p.value
+##  female - male     -675 51.2 327 -13.174  &lt;.0001
+## 
+## species = Chinstrap:
+##  contrast      estimate   SE  df t.ratio p.value
+##  female - male     -412 75.0 327  -5.487  &lt;.0001
+## 
+## species = Gentoo:
+##  contrast      estimate   SE  df t.ratio p.value
+##  female - male     -805 56.7 327 -14.188  &lt;.0001</a:t>
             </a:r>
           </a:p>
         </p:txBody>
@@ -8787,43 +8290,15 @@
               <a:rPr>
                 <a:latin typeface="Courier"/>
               </a:rPr>
-              <a:t>[1] "Sex effect (Male - Female) by species:"</a:t>
-            </a:r>
-          </a:p>
-          <a:p>
-            <a:pPr lvl="0" indent="0">
-              <a:buNone/>
-            </a:pPr>
-            <a:r>
-              <a:rPr>
-                <a:latin typeface="Courier"/>
-              </a:rPr>
-              <a:t>    Species Sex_Effect
-1    Adelie       -675
-2 Chinstrap       -412
-3    Gentoo       -805</a:t>
-            </a:r>
-          </a:p>
-          <a:p>
-            <a:pPr lvl="0" indent="0">
-              <a:buNone/>
-            </a:pPr>
-            <a:r>
-              <a:rPr>
-                <a:latin typeface="Courier"/>
-              </a:rPr>
-              <a:t>[1] "\nInteraction interpretation:"</a:t>
-            </a:r>
-          </a:p>
-          <a:p>
-            <a:pPr lvl="0" indent="0">
-              <a:buNone/>
-            </a:pPr>
-            <a:r>
-              <a:rPr>
-                <a:latin typeface="Courier"/>
-              </a:rPr>
-              <a:t>[1] "Sex effects differ across species"</a:t>
+              <a:t>## Sex effect (Male - Female) by species:
+##     Species Sex_Effect
+## 1    Adelie       -675
+## 2 Chinstrap       -412
+## 3    Gentoo       -805
+## 
+## 
+## Interaction interpretation:
+## [1] "Sex effects differ across species"</a:t>
             </a:r>
           </a:p>
         </p:txBody>
@@ -8972,76 +8447,27 @@
               <a:rPr>
                 <a:latin typeface="Courier"/>
               </a:rPr>
-              <a:t>[1] "Shapiro-Wilk test:"</a:t>
-            </a:r>
-          </a:p>
-          <a:p>
-            <a:pPr lvl="0" indent="0">
-              <a:buNone/>
-            </a:pPr>
-            <a:r>
-              <a:rPr>
-                <a:latin typeface="Courier"/>
-              </a:rPr>
-              <a:t>
-    Shapiro-Wilk normality test
-data:  residuals(model_u)
-W = 0.99776, p-value = 0.9367</a:t>
-            </a:r>
-          </a:p>
-          <a:p>
-            <a:pPr lvl="0" indent="0">
-              <a:buNone/>
-            </a:pPr>
-            <a:r>
-              <a:rPr>
-                <a:latin typeface="Courier"/>
-              </a:rPr>
-              <a:t>[1] "\nLevene's test:"</a:t>
-            </a:r>
-          </a:p>
-          <a:p>
-            <a:pPr lvl="0" indent="0">
-              <a:buNone/>
-            </a:pPr>
-            <a:r>
-              <a:rPr>
-                <a:latin typeface="Courier"/>
-              </a:rPr>
-              <a:t>Levene's Test for Homogeneity of Variance (center = median)
-       Df F value Pr(&gt;F)
-group   5  1.3908 0.2272
-      327               </a:t>
-            </a:r>
-          </a:p>
-          <a:p>
-            <a:pPr lvl="0" indent="0">
-              <a:buNone/>
-            </a:pPr>
-            <a:r>
-              <a:rPr>
-                <a:latin typeface="Courier"/>
-              </a:rPr>
-              <a:t>[1] "\nResidual SD by group:"</a:t>
-            </a:r>
-          </a:p>
-          <a:p>
-            <a:pPr lvl="0" indent="0">
-              <a:buNone/>
-            </a:pPr>
-            <a:r>
-              <a:rPr>
-                <a:latin typeface="Courier"/>
-              </a:rPr>
-              <a:t># A tibble: 6 × 3
-  species   sex    sd_resid
-  &lt;fct&gt;     &lt;fct&gt;     &lt;dbl&gt;
-1 Adelie    female     269.
-2 Adelie    male       347.
-3 Chinstrap female     285.
-4 Chinstrap male       362.
-5 Gentoo    female     282.
-6 Gentoo    male       313.</a:t>
+              <a:t>## [1] "Shapiro-Wilk test:"
+## 
+##  Shapiro-Wilk normality test
+## 
+## data:  residuals(model_u)
+## W = 0.99776, p-value = 0.9367
+## [1] "\nLevene's test:"
+## Levene's Test for Homogeneity of Variance (center = median)
+##        Df F value Pr(&gt;F)
+## group   5  1.3908 0.2272
+##       327
+## [1] "\nResidual SD by group:"
+## # A tibble: 6 × 3
+##   species   sex    sd_resid
+##   &lt;fct&gt;     &lt;fct&gt;     &lt;dbl&gt;
+## 1 Adelie    female     269.
+## 2 Adelie    male       347.
+## 3 Chinstrap female     285.
+## 4 Chinstrap male       362.
+## 5 Gentoo    female     282.
+## 6 Gentoo    male       313.</a:t>
             </a:r>
           </a:p>
         </p:txBody>
@@ -9132,65 +8558,17 @@
               <a:rPr>
                 <a:latin typeface="Courier"/>
               </a:rPr>
-              <a:t>[1] "Balanced vs Unbalanced Results:"</a:t>
-            </a:r>
-          </a:p>
-          <a:p>
-            <a:pPr lvl="0" indent="0">
-              <a:buNone/>
-            </a:pPr>
-            <a:r>
-              <a:rPr>
-                <a:latin typeface="Courier"/>
-              </a:rPr>
-              <a:t>       Effect Balanced_F Balanced_p Unbalanced_F Unbalanced_p
-1     Species     477.20      0e+00       746.92        0e+00
-2         Sex     239.22      0e+00       311.84        0e+00
-3 Interaction       9.10      2e-04         8.76        2e-04</a:t>
-            </a:r>
-          </a:p>
-          <a:p>
-            <a:pPr lvl="0" indent="0">
-              <a:buNone/>
-            </a:pPr>
-            <a:r>
-              <a:rPr>
-                <a:latin typeface="Courier"/>
-              </a:rPr>
-              <a:t>[1] "\nSample sizes:"</a:t>
-            </a:r>
-          </a:p>
-          <a:p>
-            <a:pPr lvl="0" indent="0">
-              <a:buNone/>
-            </a:pPr>
-            <a:r>
-              <a:rPr>
-                <a:latin typeface="Courier"/>
-              </a:rPr>
-              <a:t>[1] "Balanced total N: 204"</a:t>
-            </a:r>
-          </a:p>
-          <a:p>
-            <a:pPr lvl="0" indent="0">
-              <a:buNone/>
-            </a:pPr>
-            <a:r>
-              <a:rPr>
-                <a:latin typeface="Courier"/>
-              </a:rPr>
-              <a:t>[1] "Unbalanced total N: 333"</a:t>
-            </a:r>
-          </a:p>
-          <a:p>
-            <a:pPr lvl="0" indent="0">
-              <a:buNone/>
-            </a:pPr>
-            <a:r>
-              <a:rPr>
-                <a:latin typeface="Courier"/>
-              </a:rPr>
-              <a:t>[1] "Data discarded: 129 observations"</a:t>
+              <a:t>## Balanced vs Unbalanced Results:
+##        Effect Balanced_F Balanced_p Unbalanced_F Unbalanced_p
+## 1     Species     477.20      0e+00       746.92        0e+00
+## 2         Sex     239.22      0e+00       311.84        0e+00
+## 3 Interaction       9.10      2e-04         8.76        2e-04
+## 
+## 
+## Sample sizes:
+## Balanced total N: 204
+## Unbalanced total N: 333
+## Data discarded: 129 observations</a:t>
             </a:r>
           </a:p>
         </p:txBody>
@@ -9880,15 +9258,15 @@
               <a:rPr>
                 <a:latin typeface="Courier"/>
               </a:rPr>
-              <a:t># A tibble: 6 × 6
-  species   sex        n mean_mass sd_mass se_mass
-  &lt;fct&gt;     &lt;fct&gt;  &lt;int&gt;     &lt;dbl&gt;   &lt;dbl&gt;   &lt;dbl&gt;
-1 Adelie    female    73     3369.    269.    31.5
-2 Adelie    male      73     4043.    347.    40.6
-3 Chinstrap female    34     3527.    285.    48.9
-4 Chinstrap male      34     3939.    362.    62.1
-5 Gentoo    female    58     4680.    282.    37.0
-6 Gentoo    male      61     5485.    313.    40.1</a:t>
+              <a:t>## # A tibble: 6 × 6
+##   species   sex        n mean_mass sd_mass se_mass
+##   &lt;fct&gt;     &lt;fct&gt;  &lt;int&gt;     &lt;dbl&gt;   &lt;dbl&gt;   &lt;dbl&gt;
+## 1 Adelie    female    73     3369.    269.    31.5
+## 2 Adelie    male      73     4043.    347.    40.6
+## 3 Chinstrap female    34     3527.    285.    48.9
+## 4 Chinstrap male      34     3939.    362.    62.1
+## 5 Gentoo    female    58     4680.    282.    37.0
+## 6 Gentoo    male      61     5485.    313.    40.1</a:t>
             </a:r>
           </a:p>
         </p:txBody>
@@ -9991,12 +9369,12 @@
               <a:rPr>
                 <a:latin typeface="Courier"/>
               </a:rPr>
-              <a:t># A tibble: 3 × 3
-  species   female  male
-  &lt;fct&gt;      &lt;int&gt; &lt;int&gt;
-1 Adelie        73    73
-2 Chinstrap     34    34
-3 Gentoo        58    61</a:t>
+              <a:t>## # A tibble: 3 × 3
+##   species   female  male
+##   &lt;fct&gt;      &lt;int&gt; &lt;int&gt;
+## 1 Adelie        73    73
+## 2 Chinstrap     34    34
+## 3 Gentoo        58    61</a:t>
             </a:r>
           </a:p>
         </p:txBody>
@@ -10025,23 +9403,13 @@
                   <a:rPr>
                     <a:latin typeface="Courier"/>
                   </a:rPr>
-                  <a:t>[1] "Minimum n = 34"</a:t>
-                </a:r>
-              </a:p>
-              <a:p>
-                <a:pPr lvl="0" indent="0">
-                  <a:buNone/>
-                </a:pPr>
-                <a:r>
-                  <a:rPr>
-                    <a:latin typeface="Courier"/>
-                  </a:rPr>
-                  <a:t># A tibble: 3 × 3
-  species   female  male
-  &lt;fct&gt;      &lt;int&gt; &lt;int&gt;
-1 Adelie        34    34
-2 Chinstrap     34    34
-3 Gentoo        34    34</a:t>
+                  <a:t>## Minimum n = 34
+## # A tibble: 3 × 3
+##   species   female  male
+##   &lt;fct&gt;      &lt;int&gt; &lt;int&gt;
+## 1 Adelie        34    34
+## 2 Chinstrap     34    34
+## 3 Gentoo        34    34</a:t>
                 </a:r>
               </a:p>
               <a:p>
@@ -10418,15 +9786,15 @@
               <a:rPr>
                 <a:latin typeface="Courier"/>
               </a:rPr>
-              <a:t># A tibble: 6 × 6
-  species   sex        n mean_mass sd_mass se_mass
-  &lt;fct&gt;     &lt;fct&gt;  &lt;int&gt;     &lt;dbl&gt;   &lt;dbl&gt;   &lt;dbl&gt;
-1 Adelie    female    34     3335.    260.    44.5
-2 Adelie    male      34     4049.    318.    54.5
-3 Chinstrap female    34     3527.    285.    48.9
-4 Chinstrap male      34     3939.    362.    62.1
-5 Gentoo    female    34     4681.    309.    53.0
-6 Gentoo    male      34     5525     274.    47.0</a:t>
+              <a:t>## # A tibble: 6 × 6
+##   species   sex        n mean_mass sd_mass se_mass
+##   &lt;fct&gt;     &lt;fct&gt;  &lt;int&gt;     &lt;dbl&gt;   &lt;dbl&gt;   &lt;dbl&gt;
+## 1 Adelie    female    34     3335.    260.    44.5
+## 2 Adelie    male      34     4049.    318.    54.5
+## 3 Chinstrap female    34     3527.    285.    48.9
+## 4 Chinstrap male      34     3939.    362.    62.1
+## 5 Gentoo    female    34     4681.    309.    53.0
+## 6 Gentoo    male      34     5525     274.    47.0</a:t>
             </a:r>
           </a:p>
         </p:txBody>

</xml_diff>